<commit_message>
chore: resolve repository audit findings (URLs, MIT license, pinned deps, Slide 4 wording, SQL runner, pytest suite)
</commit_message>
<xml_diff>
--- a/docs/presentation/clinic_operations_executive_briefing.pptx
+++ b/docs/presentation/clinic_operations_executive_briefing.pptx
@@ -5542,7 +5542,7 @@
               </a:defRPr>
             </a:pPr>
             <a:r>
-              <a:t>Algorithmic data cleaning pipeline resolving 6 real-world EHR anomalies to ensure cohort integrity</a:t>
+              <a:t>Algorithmic data cleaning pipeline resolving 6 simulated EHR anomalies to ensure cohort integrity</a:t>
             </a:r>
           </a:p>
         </p:txBody>
@@ -5679,7 +5679,7 @@
               </a:defRPr>
             </a:pPr>
             <a:r>
-              <a:t>16,998 Visits Audited</a:t>
+              <a:t>17,004 Audited → 16,998 Clean</a:t>
             </a:r>
           </a:p>
           <a:p>
@@ -6418,7 +6418,7 @@
               </a:defRPr>
             </a:pPr>
             <a:r>
-              <a:t>All 16,998 analyzed encounters were algorithmically audited across 5 relational constraints, ensuring 100% compliance before statistical modeling.</a:t>
+              <a:t>All 17,004 raw records were algorithmically audited across 5 relational constraints; 16,998 clean encounters were retained for statistical modeling.</a:t>
             </a:r>
           </a:p>
         </p:txBody>

</xml_diff>